<commit_message>
Expand the child-friendly daily news to three stories
Use a natural single-page web layout and a compact two-slide deck, with date and weather kept in the top-right corner.
</commit_message>
<xml_diff>
--- a/daily-news/2026-09-28/今日新闻-2026-09-28.pptx
+++ b/daily-news/2026-09-28/今日新闻-2026-09-28.pptx
@@ -3104,7 +3104,7 @@
             <a:avLst/>
           </a:prstGeom>
           <a:solidFill>
-            <a:srgbClr val="FFF5CC"/>
+            <a:srgbClr val="FFF9E8"/>
           </a:solidFill>
           <a:ln>
             <a:noFill/>
@@ -3141,8 +3141,8 @@
         </p:nvSpPr>
         <p:spPr>
           <a:xfrm>
-            <a:off x="658368" y="502920"/>
-            <a:ext cx="4572000" cy="365760"/>
+            <a:off x="594360" y="320040"/>
+            <a:ext cx="3931920" cy="502920"/>
           </a:xfrm>
           <a:prstGeom prst="rect">
             <a:avLst/>
@@ -3161,14 +3161,14 @@
               </a:spcAft>
             </a:pPr>
             <a:r>
-              <a:rPr sz="1400" b="1">
+              <a:rPr sz="2800" b="1">
                 <a:solidFill>
-                  <a:srgbClr val="FF6475"/>
+                  <a:srgbClr val="26384A"/>
                 </a:solidFill>
                 <a:latin typeface="PingFang SC"/>
                 <a:ea typeface="PingFang SC"/>
               </a:rPr>
-              <a:t>小小新闻 · 第1页</a:t>
+              <a:t>小小新闻</a:t>
             </a:r>
           </a:p>
         </p:txBody>
@@ -3181,8 +3181,8 @@
         </p:nvSpPr>
         <p:spPr>
           <a:xfrm>
-            <a:off x="658368" y="1005840"/>
-            <a:ext cx="4434840" cy="594360"/>
+            <a:off x="7452360" y="310896"/>
+            <a:ext cx="4114800" cy="475488"/>
           </a:xfrm>
           <a:prstGeom prst="roundRect">
             <a:avLst/>
@@ -3225,8 +3225,8 @@
         </p:nvSpPr>
         <p:spPr>
           <a:xfrm>
-            <a:off x="868680" y="1143000"/>
-            <a:ext cx="4023360" cy="274320"/>
+            <a:off x="7616952" y="420624"/>
+            <a:ext cx="3794760" cy="210312"/>
           </a:xfrm>
           <a:prstGeom prst="rect">
             <a:avLst/>
@@ -3239,120 +3239,40 @@
           </a:bodyPr>
           <a:lstStyle/>
           <a:p>
-            <a:pPr algn="l">
+            <a:pPr algn="ctr">
               <a:spcAft>
                 <a:spcPts val="0"/>
               </a:spcAft>
             </a:pPr>
             <a:r>
-              <a:rPr sz="1700" b="1">
+              <a:rPr sz="1200" b="1">
                 <a:solidFill>
                   <a:srgbClr val="26384A"/>
                 </a:solidFill>
                 <a:latin typeface="PingFang SC"/>
                 <a:ea typeface="PingFang SC"/>
               </a:rPr>
-              <a:t>9月28日  星期一  上海</a:t>
-            </a:r>
-          </a:p>
-        </p:txBody>
-      </p:sp>
-      <p:sp>
-        <p:nvSpPr>
-          <p:cNvPr id="6" name="TextBox 5"/>
-          <p:cNvSpPr txBox="1"/>
-          <p:nvPr/>
-        </p:nvSpPr>
-        <p:spPr>
-          <a:xfrm>
-            <a:off x="640080" y="1874519"/>
-            <a:ext cx="5943600" cy="1097280"/>
-          </a:xfrm>
-          <a:prstGeom prst="rect">
-            <a:avLst/>
-          </a:prstGeom>
-          <a:noFill/>
-        </p:spPr>
-        <p:txBody>
-          <a:bodyPr wrap="square" lIns="36576" rIns="36576" tIns="27432" bIns="27432">
-            <a:noAutofit/>
-          </a:bodyPr>
-          <a:lstStyle/>
-          <a:p>
-            <a:pPr algn="l">
-              <a:spcAft>
-                <a:spcPts val="0"/>
-              </a:spcAft>
-            </a:pPr>
-            <a:r>
-              <a:rPr sz="4800" b="1">
-                <a:solidFill>
-                  <a:srgbClr val="26384A"/>
-                </a:solidFill>
-                <a:latin typeface="PingFang SC"/>
-                <a:ea typeface="PingFang SC"/>
-              </a:rPr>
-              <a:t>今天有小雨</a:t>
-            </a:r>
-          </a:p>
-        </p:txBody>
-      </p:sp>
-      <p:sp>
-        <p:nvSpPr>
-          <p:cNvPr id="7" name="TextBox 6"/>
-          <p:cNvSpPr txBox="1"/>
-          <p:nvPr/>
-        </p:nvSpPr>
-        <p:spPr>
-          <a:xfrm>
-            <a:off x="658368" y="3154680"/>
-            <a:ext cx="3840480" cy="731520"/>
-          </a:xfrm>
-          <a:prstGeom prst="rect">
-            <a:avLst/>
-          </a:prstGeom>
-          <a:noFill/>
-        </p:spPr>
-        <p:txBody>
-          <a:bodyPr wrap="square" lIns="36576" rIns="36576" tIns="27432" bIns="27432">
-            <a:noAutofit/>
-          </a:bodyPr>
-          <a:lstStyle/>
-          <a:p>
-            <a:pPr algn="l">
-              <a:spcAft>
-                <a:spcPts val="0"/>
-              </a:spcAft>
-            </a:pPr>
-            <a:r>
-              <a:rPr sz="3400" b="1">
-                <a:solidFill>
-                  <a:srgbClr val="FF6475"/>
-                </a:solidFill>
-                <a:latin typeface="PingFang SC"/>
-                <a:ea typeface="PingFang SC"/>
-              </a:rPr>
-              <a:t>23—25℃</a:t>
-            </a:r>
-          </a:p>
-        </p:txBody>
-      </p:sp>
-      <p:sp>
-        <p:nvSpPr>
-          <p:cNvPr id="8" name="Rounded Rectangle 7"/>
+              <a:t>9月28日 星期一　上海 小雨 23—25℃</a:t>
+            </a:r>
+          </a:p>
+        </p:txBody>
+      </p:sp>
+      <p:sp>
+        <p:nvSpPr>
+          <p:cNvPr id="6" name="Rounded Rectangle 5"/>
           <p:cNvSpPr/>
           <p:nvPr/>
         </p:nvSpPr>
         <p:spPr>
           <a:xfrm>
-            <a:off x="658368" y="4160520"/>
-            <a:ext cx="4983480" cy="749808"/>
+            <a:off x="566928" y="1143000"/>
+            <a:ext cx="5303520" cy="4983480"/>
           </a:xfrm>
           <a:prstGeom prst="roundRect">
             <a:avLst/>
           </a:prstGeom>
           <a:solidFill>
-            <a:srgbClr val="FFFFFF"/>
+            <a:srgbClr val="EAF8EF"/>
           </a:solidFill>
           <a:ln>
             <a:noFill/>
@@ -3381,58 +3301,43 @@
           </a:p>
         </p:txBody>
       </p:sp>
-      <p:sp>
-        <p:nvSpPr>
-          <p:cNvPr id="9" name="TextBox 8"/>
-          <p:cNvSpPr txBox="1"/>
+      <p:pic>
+        <p:nvPicPr>
+          <p:cNvPr id="7" name="Picture 6" descr="pandas.jpg"/>
+          <p:cNvPicPr>
+            <a:picLocks noChangeAspect="1"/>
+          </p:cNvPicPr>
           <p:nvPr/>
-        </p:nvSpPr>
-        <p:spPr>
-          <a:xfrm>
-            <a:off x="886968" y="4352544"/>
-            <a:ext cx="4572000" cy="329184"/>
+        </p:nvPicPr>
+        <p:blipFill>
+          <a:blip r:embed="rId2"/>
+          <a:srcRect t="5880" b="5880"/>
+          <a:stretch>
+            <a:fillRect/>
+          </a:stretch>
+        </p:blipFill>
+        <p:spPr>
+          <a:xfrm>
+            <a:off x="713232" y="1298448"/>
+            <a:ext cx="5010912" cy="2487168"/>
           </a:xfrm>
           <a:prstGeom prst="rect">
             <a:avLst/>
           </a:prstGeom>
-          <a:noFill/>
-        </p:spPr>
-        <p:txBody>
-          <a:bodyPr wrap="square" lIns="36576" rIns="36576" tIns="27432" bIns="27432">
-            <a:noAutofit/>
-          </a:bodyPr>
-          <a:lstStyle/>
-          <a:p>
-            <a:pPr algn="l">
-              <a:spcAft>
-                <a:spcPts val="0"/>
-              </a:spcAft>
-            </a:pPr>
-            <a:r>
-              <a:rPr sz="2100" b="1">
-                <a:solidFill>
-                  <a:srgbClr val="26384A"/>
-                </a:solidFill>
-                <a:latin typeface="PingFang SC"/>
-                <a:ea typeface="PingFang SC"/>
-              </a:rPr>
-              <a:t>带小伞，小心地上滑。</a:t>
-            </a:r>
-          </a:p>
-        </p:txBody>
-      </p:sp>
-      <p:sp>
-        <p:nvSpPr>
-          <p:cNvPr id="10" name="Oval 9"/>
+        </p:spPr>
+      </p:pic>
+      <p:sp>
+        <p:nvSpPr>
+          <p:cNvPr id="8" name="Rounded Rectangle 7"/>
           <p:cNvSpPr/>
           <p:nvPr/>
         </p:nvSpPr>
         <p:spPr>
           <a:xfrm>
-            <a:off x="9052560" y="685800"/>
-            <a:ext cx="1325880" cy="1325880"/>
-          </a:xfrm>
-          <a:prstGeom prst="ellipse">
+            <a:off x="859536" y="1444752"/>
+            <a:ext cx="502920" cy="502920"/>
+          </a:xfrm>
+          <a:prstGeom prst="roundRect">
             <a:avLst/>
           </a:prstGeom>
           <a:solidFill>
@@ -3467,20 +3372,181 @@
       </p:sp>
       <p:sp>
         <p:nvSpPr>
-          <p:cNvPr id="11" name="Rounded Rectangle 10"/>
+          <p:cNvPr id="9" name="TextBox 8"/>
+          <p:cNvSpPr txBox="1"/>
+          <p:nvPr/>
+        </p:nvSpPr>
+        <p:spPr>
+          <a:xfrm>
+            <a:off x="859536" y="1572768"/>
+            <a:ext cx="502920" cy="219456"/>
+          </a:xfrm>
+          <a:prstGeom prst="rect">
+            <a:avLst/>
+          </a:prstGeom>
+          <a:noFill/>
+        </p:spPr>
+        <p:txBody>
+          <a:bodyPr wrap="square" lIns="36576" rIns="36576" tIns="27432" bIns="27432">
+            <a:noAutofit/>
+          </a:bodyPr>
+          <a:lstStyle/>
+          <a:p>
+            <a:pPr algn="ctr">
+              <a:spcAft>
+                <a:spcPts val="0"/>
+              </a:spcAft>
+            </a:pPr>
+            <a:r>
+              <a:rPr sz="1500" b="1">
+                <a:solidFill>
+                  <a:srgbClr val="26384A"/>
+                </a:solidFill>
+                <a:latin typeface="PingFang SC"/>
+                <a:ea typeface="PingFang SC"/>
+              </a:rPr>
+              <a:t>1</a:t>
+            </a:r>
+          </a:p>
+        </p:txBody>
+      </p:sp>
+      <p:sp>
+        <p:nvSpPr>
+          <p:cNvPr id="10" name="TextBox 9"/>
+          <p:cNvSpPr txBox="1"/>
+          <p:nvPr/>
+        </p:nvSpPr>
+        <p:spPr>
+          <a:xfrm>
+            <a:off x="822960" y="3977639"/>
+            <a:ext cx="4754880" cy="457200"/>
+          </a:xfrm>
+          <a:prstGeom prst="rect">
+            <a:avLst/>
+          </a:prstGeom>
+          <a:noFill/>
+        </p:spPr>
+        <p:txBody>
+          <a:bodyPr wrap="square" lIns="36576" rIns="36576" tIns="27432" bIns="27432">
+            <a:noAutofit/>
+          </a:bodyPr>
+          <a:lstStyle/>
+          <a:p>
+            <a:pPr algn="l">
+              <a:spcAft>
+                <a:spcPts val="0"/>
+              </a:spcAft>
+            </a:pPr>
+            <a:r>
+              <a:rPr sz="2500" b="1">
+                <a:solidFill>
+                  <a:srgbClr val="26384A"/>
+                </a:solidFill>
+                <a:latin typeface="PingFang SC"/>
+                <a:ea typeface="PingFang SC"/>
+              </a:rPr>
+              <a:t>熊猫坐飞机</a:t>
+            </a:r>
+          </a:p>
+        </p:txBody>
+      </p:sp>
+      <p:sp>
+        <p:nvSpPr>
+          <p:cNvPr id="11" name="TextBox 10"/>
+          <p:cNvSpPr txBox="1"/>
+          <p:nvPr/>
+        </p:nvSpPr>
+        <p:spPr>
+          <a:xfrm>
+            <a:off x="822960" y="4507992"/>
+            <a:ext cx="4754880" cy="640080"/>
+          </a:xfrm>
+          <a:prstGeom prst="rect">
+            <a:avLst/>
+          </a:prstGeom>
+          <a:noFill/>
+        </p:spPr>
+        <p:txBody>
+          <a:bodyPr wrap="square" lIns="36576" rIns="36576" tIns="27432" bIns="27432">
+            <a:noAutofit/>
+          </a:bodyPr>
+          <a:lstStyle/>
+          <a:p>
+            <a:pPr algn="l">
+              <a:spcAft>
+                <a:spcPts val="0"/>
+              </a:spcAft>
+            </a:pPr>
+            <a:r>
+              <a:rPr sz="1900" b="0">
+                <a:solidFill>
+                  <a:srgbClr val="26384A"/>
+                </a:solidFill>
+                <a:latin typeface="PingFang SC"/>
+                <a:ea typeface="PingFang SC"/>
+              </a:rPr>
+              <a:t>平平和福双到了新家。
+它们先要好好休息。</a:t>
+            </a:r>
+          </a:p>
+        </p:txBody>
+      </p:sp>
+      <p:sp>
+        <p:nvSpPr>
+          <p:cNvPr id="12" name="TextBox 11"/>
+          <p:cNvSpPr txBox="1"/>
+          <p:nvPr/>
+        </p:nvSpPr>
+        <p:spPr>
+          <a:xfrm>
+            <a:off x="822960" y="5367528"/>
+            <a:ext cx="4754880" cy="320040"/>
+          </a:xfrm>
+          <a:prstGeom prst="rect">
+            <a:avLst/>
+          </a:prstGeom>
+          <a:noFill/>
+        </p:spPr>
+        <p:txBody>
+          <a:bodyPr wrap="square" lIns="36576" rIns="36576" tIns="27432" bIns="27432">
+            <a:noAutofit/>
+          </a:bodyPr>
+          <a:lstStyle/>
+          <a:p>
+            <a:pPr algn="l">
+              <a:spcAft>
+                <a:spcPts val="0"/>
+              </a:spcAft>
+            </a:pPr>
+            <a:r>
+              <a:rPr sz="1600" b="1">
+                <a:solidFill>
+                  <a:srgbClr val="FF6475"/>
+                </a:solidFill>
+                <a:latin typeface="PingFang SC"/>
+                <a:ea typeface="PingFang SC"/>
+              </a:rPr>
+              <a:t>你想送熊猫什么礼物？</a:t>
+            </a:r>
+          </a:p>
+        </p:txBody>
+      </p:sp>
+      <p:sp>
+        <p:nvSpPr>
+          <p:cNvPr id="13" name="Rounded Rectangle 12"/>
           <p:cNvSpPr/>
           <p:nvPr/>
         </p:nvSpPr>
         <p:spPr>
           <a:xfrm>
-            <a:off x="6583680" y="2514600"/>
-            <a:ext cx="4114800" cy="1234440"/>
+            <a:off x="6309360" y="1143000"/>
+            <a:ext cx="5303520" cy="4983480"/>
           </a:xfrm>
           <a:prstGeom prst="roundRect">
             <a:avLst/>
           </a:prstGeom>
           <a:solidFill>
-            <a:srgbClr val="FFFFFF"/>
+            <a:srgbClr val="EAF5FF"/>
           </a:solidFill>
           <a:ln>
             <a:noFill/>
@@ -3509,22 +3575,47 @@
           </a:p>
         </p:txBody>
       </p:sp>
-      <p:sp>
-        <p:nvSpPr>
-          <p:cNvPr id="12" name="Oval 11"/>
+      <p:pic>
+        <p:nvPicPr>
+          <p:cNvPr id="14" name="Picture 13" descr="science-letters.jpg"/>
+          <p:cNvPicPr>
+            <a:picLocks noChangeAspect="1"/>
+          </p:cNvPicPr>
+          <p:nvPr/>
+        </p:nvPicPr>
+        <p:blipFill>
+          <a:blip r:embed="rId3"/>
+          <a:srcRect t="10917" b="10917"/>
+          <a:stretch>
+            <a:fillRect/>
+          </a:stretch>
+        </p:blipFill>
+        <p:spPr>
+          <a:xfrm>
+            <a:off x="6455664" y="1298448"/>
+            <a:ext cx="5010912" cy="2487168"/>
+          </a:xfrm>
+          <a:prstGeom prst="rect">
+            <a:avLst/>
+          </a:prstGeom>
+        </p:spPr>
+      </p:pic>
+      <p:sp>
+        <p:nvSpPr>
+          <p:cNvPr id="15" name="Rounded Rectangle 14"/>
           <p:cNvSpPr/>
           <p:nvPr/>
         </p:nvSpPr>
         <p:spPr>
           <a:xfrm>
-            <a:off x="7086600" y="1993392"/>
-            <a:ext cx="1325880" cy="1325880"/>
-          </a:xfrm>
-          <a:prstGeom prst="ellipse">
+            <a:off x="6601968" y="1444752"/>
+            <a:ext cx="502920" cy="502920"/>
+          </a:xfrm>
+          <a:prstGeom prst="roundRect">
             <a:avLst/>
           </a:prstGeom>
           <a:solidFill>
-            <a:srgbClr val="FFFFFF"/>
+            <a:srgbClr val="FFD75E"/>
           </a:solidFill>
           <a:ln>
             <a:noFill/>
@@ -3555,234 +3646,54 @@
       </p:sp>
       <p:sp>
         <p:nvSpPr>
-          <p:cNvPr id="13" name="Oval 12"/>
-          <p:cNvSpPr/>
+          <p:cNvPr id="16" name="TextBox 15"/>
+          <p:cNvSpPr txBox="1"/>
           <p:nvPr/>
         </p:nvSpPr>
         <p:spPr>
           <a:xfrm>
-            <a:off x="8229600" y="1719072"/>
-            <a:ext cx="1645920" cy="1645920"/>
-          </a:xfrm>
-          <a:prstGeom prst="ellipse">
+            <a:off x="6601968" y="1572768"/>
+            <a:ext cx="502920" cy="219456"/>
+          </a:xfrm>
+          <a:prstGeom prst="rect">
             <a:avLst/>
           </a:prstGeom>
-          <a:solidFill>
-            <a:srgbClr val="FFFFFF"/>
-          </a:solidFill>
-          <a:ln>
-            <a:noFill/>
-          </a:ln>
-          <a:effectLst/>
-        </p:spPr>
-        <p:style>
-          <a:lnRef idx="1">
-            <a:schemeClr val="accent1"/>
-          </a:lnRef>
-          <a:fillRef idx="3">
-            <a:schemeClr val="accent1"/>
-          </a:fillRef>
-          <a:effectRef idx="2">
-            <a:schemeClr val="accent1"/>
-          </a:effectRef>
-          <a:fontRef idx="minor">
-            <a:schemeClr val="lt1"/>
-          </a:fontRef>
-        </p:style>
-        <p:txBody>
-          <a:bodyPr rtlCol="0" anchor="ctr"/>
-          <a:lstStyle/>
-          <a:p>
-            <a:pPr algn="ctr"/>
-          </a:p>
-        </p:txBody>
-      </p:sp>
-      <p:sp>
-        <p:nvSpPr>
-          <p:cNvPr id="14" name="Teardrop 13"/>
-          <p:cNvSpPr/>
-          <p:nvPr/>
-        </p:nvSpPr>
-        <p:spPr>
-          <a:xfrm>
-            <a:off x="7086600" y="3977639"/>
-            <a:ext cx="256032" cy="530352"/>
-          </a:xfrm>
-          <a:prstGeom prst="teardrop">
-            <a:avLst/>
-          </a:prstGeom>
-          <a:solidFill>
-            <a:srgbClr val="78CCEF"/>
-          </a:solidFill>
-          <a:ln>
-            <a:noFill/>
-          </a:ln>
-          <a:effectLst/>
-        </p:spPr>
-        <p:style>
-          <a:lnRef idx="1">
-            <a:schemeClr val="accent1"/>
-          </a:lnRef>
-          <a:fillRef idx="3">
-            <a:schemeClr val="accent1"/>
-          </a:fillRef>
-          <a:effectRef idx="2">
-            <a:schemeClr val="accent1"/>
-          </a:effectRef>
-          <a:fontRef idx="minor">
-            <a:schemeClr val="lt1"/>
-          </a:fontRef>
-        </p:style>
-        <p:txBody>
-          <a:bodyPr rtlCol="0" anchor="ctr"/>
-          <a:lstStyle/>
-          <a:p>
-            <a:pPr algn="ctr"/>
-          </a:p>
-        </p:txBody>
-      </p:sp>
-      <p:sp>
-        <p:nvSpPr>
-          <p:cNvPr id="15" name="Teardrop 14"/>
-          <p:cNvSpPr/>
-          <p:nvPr/>
-        </p:nvSpPr>
-        <p:spPr>
-          <a:xfrm>
-            <a:off x="7955279" y="3977639"/>
-            <a:ext cx="256032" cy="530352"/>
-          </a:xfrm>
-          <a:prstGeom prst="teardrop">
-            <a:avLst/>
-          </a:prstGeom>
-          <a:solidFill>
-            <a:srgbClr val="78CCEF"/>
-          </a:solidFill>
-          <a:ln>
-            <a:noFill/>
-          </a:ln>
-          <a:effectLst/>
-        </p:spPr>
-        <p:style>
-          <a:lnRef idx="1">
-            <a:schemeClr val="accent1"/>
-          </a:lnRef>
-          <a:fillRef idx="3">
-            <a:schemeClr val="accent1"/>
-          </a:fillRef>
-          <a:effectRef idx="2">
-            <a:schemeClr val="accent1"/>
-          </a:effectRef>
-          <a:fontRef idx="minor">
-            <a:schemeClr val="lt1"/>
-          </a:fontRef>
-        </p:style>
-        <p:txBody>
-          <a:bodyPr rtlCol="0" anchor="ctr"/>
-          <a:lstStyle/>
-          <a:p>
-            <a:pPr algn="ctr"/>
-          </a:p>
-        </p:txBody>
-      </p:sp>
-      <p:sp>
-        <p:nvSpPr>
-          <p:cNvPr id="16" name="Teardrop 15"/>
-          <p:cNvSpPr/>
-          <p:nvPr/>
-        </p:nvSpPr>
-        <p:spPr>
-          <a:xfrm>
-            <a:off x="8823960" y="3977639"/>
-            <a:ext cx="256032" cy="530352"/>
-          </a:xfrm>
-          <a:prstGeom prst="teardrop">
-            <a:avLst/>
-          </a:prstGeom>
-          <a:solidFill>
-            <a:srgbClr val="78CCEF"/>
-          </a:solidFill>
-          <a:ln>
-            <a:noFill/>
-          </a:ln>
-          <a:effectLst/>
-        </p:spPr>
-        <p:style>
-          <a:lnRef idx="1">
-            <a:schemeClr val="accent1"/>
-          </a:lnRef>
-          <a:fillRef idx="3">
-            <a:schemeClr val="accent1"/>
-          </a:fillRef>
-          <a:effectRef idx="2">
-            <a:schemeClr val="accent1"/>
-          </a:effectRef>
-          <a:fontRef idx="minor">
-            <a:schemeClr val="lt1"/>
-          </a:fontRef>
-        </p:style>
-        <p:txBody>
-          <a:bodyPr rtlCol="0" anchor="ctr"/>
-          <a:lstStyle/>
-          <a:p>
-            <a:pPr algn="ctr"/>
-          </a:p>
-        </p:txBody>
-      </p:sp>
-      <p:sp>
-        <p:nvSpPr>
-          <p:cNvPr id="17" name="Teardrop 16"/>
-          <p:cNvSpPr/>
-          <p:nvPr/>
-        </p:nvSpPr>
-        <p:spPr>
-          <a:xfrm>
-            <a:off x="9692640" y="3977639"/>
-            <a:ext cx="256032" cy="530352"/>
-          </a:xfrm>
-          <a:prstGeom prst="teardrop">
-            <a:avLst/>
-          </a:prstGeom>
-          <a:solidFill>
-            <a:srgbClr val="78CCEF"/>
-          </a:solidFill>
-          <a:ln>
-            <a:noFill/>
-          </a:ln>
-          <a:effectLst/>
-        </p:spPr>
-        <p:style>
-          <a:lnRef idx="1">
-            <a:schemeClr val="accent1"/>
-          </a:lnRef>
-          <a:fillRef idx="3">
-            <a:schemeClr val="accent1"/>
-          </a:fillRef>
-          <a:effectRef idx="2">
-            <a:schemeClr val="accent1"/>
-          </a:effectRef>
-          <a:fontRef idx="minor">
-            <a:schemeClr val="lt1"/>
-          </a:fontRef>
-        </p:style>
-        <p:txBody>
-          <a:bodyPr rtlCol="0" anchor="ctr"/>
-          <a:lstStyle/>
-          <a:p>
-            <a:pPr algn="ctr"/>
-          </a:p>
-        </p:txBody>
-      </p:sp>
-      <p:sp>
-        <p:nvSpPr>
-          <p:cNvPr id="18" name="TextBox 17"/>
+          <a:noFill/>
+        </p:spPr>
+        <p:txBody>
+          <a:bodyPr wrap="square" lIns="36576" rIns="36576" tIns="27432" bIns="27432">
+            <a:noAutofit/>
+          </a:bodyPr>
+          <a:lstStyle/>
+          <a:p>
+            <a:pPr algn="ctr">
+              <a:spcAft>
+                <a:spcPts val="0"/>
+              </a:spcAft>
+            </a:pPr>
+            <a:r>
+              <a:rPr sz="1500" b="1">
+                <a:solidFill>
+                  <a:srgbClr val="26384A"/>
+                </a:solidFill>
+                <a:latin typeface="PingFang SC"/>
+                <a:ea typeface="PingFang SC"/>
+              </a:rPr>
+              <a:t>2</a:t>
+            </a:r>
+          </a:p>
+        </p:txBody>
+      </p:sp>
+      <p:sp>
+        <p:nvSpPr>
+          <p:cNvPr id="17" name="TextBox 16"/>
           <p:cNvSpPr txBox="1"/>
           <p:nvPr/>
         </p:nvSpPr>
         <p:spPr>
           <a:xfrm>
-            <a:off x="694944" y="6236208"/>
-            <a:ext cx="7955279" cy="274320"/>
+            <a:off x="6565392" y="3977639"/>
+            <a:ext cx="4754880" cy="457200"/>
           </a:xfrm>
           <a:prstGeom prst="rect">
             <a:avLst/>
@@ -3801,14 +3712,55 @@
               </a:spcAft>
             </a:pPr>
             <a:r>
-              <a:rPr sz="1200" b="1">
+              <a:rPr sz="2500" b="1">
                 <a:solidFill>
-                  <a:srgbClr val="607080"/>
+                  <a:srgbClr val="26384A"/>
                 </a:solidFill>
                 <a:latin typeface="PingFang SC"/>
                 <a:ea typeface="PingFang SC"/>
               </a:rPr>
-              <a:t>大家早上好！今天上海有小雨。</a:t>
+              <a:t>一封科学来信</a:t>
+            </a:r>
+          </a:p>
+        </p:txBody>
+      </p:sp>
+      <p:sp>
+        <p:nvSpPr>
+          <p:cNvPr id="18" name="TextBox 17"/>
+          <p:cNvSpPr txBox="1"/>
+          <p:nvPr/>
+        </p:nvSpPr>
+        <p:spPr>
+          <a:xfrm>
+            <a:off x="6565392" y="4507992"/>
+            <a:ext cx="4754880" cy="640080"/>
+          </a:xfrm>
+          <a:prstGeom prst="rect">
+            <a:avLst/>
+          </a:prstGeom>
+          <a:noFill/>
+        </p:spPr>
+        <p:txBody>
+          <a:bodyPr wrap="square" lIns="36576" rIns="36576" tIns="27432" bIns="27432">
+            <a:noAutofit/>
+          </a:bodyPr>
+          <a:lstStyle/>
+          <a:p>
+            <a:pPr algn="l">
+              <a:spcAft>
+                <a:spcPts val="0"/>
+              </a:spcAft>
+            </a:pPr>
+            <a:r>
+              <a:rPr sz="1900" b="0">
+                <a:solidFill>
+                  <a:srgbClr val="26384A"/>
+                </a:solidFill>
+                <a:latin typeface="PingFang SC"/>
+                <a:ea typeface="PingFang SC"/>
+              </a:rPr>
+              <a:t>科学家写信给小朋友：
+多问为什么，勇敢想一想。</a:t>
             </a:r>
           </a:p>
         </p:txBody>
@@ -3821,8 +3773,88 @@
         </p:nvSpPr>
         <p:spPr>
           <a:xfrm>
-            <a:off x="10698480" y="6236208"/>
-            <a:ext cx="640080" cy="274320"/>
+            <a:off x="6565392" y="5367528"/>
+            <a:ext cx="4754880" cy="320040"/>
+          </a:xfrm>
+          <a:prstGeom prst="rect">
+            <a:avLst/>
+          </a:prstGeom>
+          <a:noFill/>
+        </p:spPr>
+        <p:txBody>
+          <a:bodyPr wrap="square" lIns="36576" rIns="36576" tIns="27432" bIns="27432">
+            <a:noAutofit/>
+          </a:bodyPr>
+          <a:lstStyle/>
+          <a:p>
+            <a:pPr algn="l">
+              <a:spcAft>
+                <a:spcPts val="0"/>
+              </a:spcAft>
+            </a:pPr>
+            <a:r>
+              <a:rPr sz="1600" b="1">
+                <a:solidFill>
+                  <a:srgbClr val="FF6475"/>
+                </a:solidFill>
+                <a:latin typeface="PingFang SC"/>
+                <a:ea typeface="PingFang SC"/>
+              </a:rPr>
+              <a:t>你最想问什么？</a:t>
+            </a:r>
+          </a:p>
+        </p:txBody>
+      </p:sp>
+      <p:sp>
+        <p:nvSpPr>
+          <p:cNvPr id="20" name="TextBox 19"/>
+          <p:cNvSpPr txBox="1"/>
+          <p:nvPr/>
+        </p:nvSpPr>
+        <p:spPr>
+          <a:xfrm>
+            <a:off x="594360" y="6446520"/>
+            <a:ext cx="8961120" cy="182880"/>
+          </a:xfrm>
+          <a:prstGeom prst="rect">
+            <a:avLst/>
+          </a:prstGeom>
+          <a:noFill/>
+        </p:spPr>
+        <p:txBody>
+          <a:bodyPr wrap="square" lIns="36576" rIns="36576" tIns="27432" bIns="27432">
+            <a:noAutofit/>
+          </a:bodyPr>
+          <a:lstStyle/>
+          <a:p>
+            <a:pPr algn="l">
+              <a:spcAft>
+                <a:spcPts val="0"/>
+              </a:spcAft>
+            </a:pPr>
+            <a:r>
+              <a:rPr sz="800" b="0">
+                <a:solidFill>
+                  <a:srgbClr val="617080"/>
+                </a:solidFill>
+                <a:latin typeface="PingFang SC"/>
+                <a:ea typeface="PingFang SC"/>
+              </a:rPr>
+              <a:t>新闻：新华社、中国科学院 · 2026年9月28日　图片：央视新闻、中国科学院</a:t>
+            </a:r>
+          </a:p>
+        </p:txBody>
+      </p:sp>
+      <p:sp>
+        <p:nvSpPr>
+          <p:cNvPr id="21" name="TextBox 20"/>
+          <p:cNvSpPr txBox="1"/>
+          <p:nvPr/>
+        </p:nvSpPr>
+        <p:spPr>
+          <a:xfrm>
+            <a:off x="10744200" y="6419088"/>
+            <a:ext cx="594360" cy="201168"/>
           </a:xfrm>
           <a:prstGeom prst="rect">
             <a:avLst/>
@@ -3841,9 +3873,9 @@
               </a:spcAft>
             </a:pPr>
             <a:r>
-              <a:rPr sz="1100" b="1">
+              <a:rPr sz="900" b="1">
                 <a:solidFill>
-                  <a:srgbClr val="607080"/>
+                  <a:srgbClr val="617080"/>
                 </a:solidFill>
                 <a:latin typeface="PingFang SC"/>
                 <a:ea typeface="PingFang SC"/>
@@ -3886,7 +3918,7 @@
             <a:avLst/>
           </a:prstGeom>
           <a:solidFill>
-            <a:srgbClr val="EAF8EF"/>
+            <a:srgbClr val="FFF9E8"/>
           </a:solidFill>
           <a:ln>
             <a:noFill/>
@@ -3915,31 +3947,46 @@
           </a:p>
         </p:txBody>
       </p:sp>
-      <p:pic>
-        <p:nvPicPr>
-          <p:cNvPr id="3" name="Picture 2" descr="pandas.jpg"/>
-          <p:cNvPicPr>
-            <a:picLocks noChangeAspect="1"/>
-          </p:cNvPicPr>
+      <p:sp>
+        <p:nvSpPr>
+          <p:cNvPr id="3" name="TextBox 2"/>
+          <p:cNvSpPr txBox="1"/>
           <p:nvPr/>
-        </p:nvPicPr>
-        <p:blipFill>
-          <a:blip r:embed="rId2"/>
-          <a:srcRect l="17231" r="17231"/>
-          <a:stretch>
-            <a:fillRect/>
-          </a:stretch>
-        </p:blipFill>
-        <p:spPr>
-          <a:xfrm>
-            <a:off x="566928" y="548640"/>
-            <a:ext cx="5806440" cy="4983480"/>
+        </p:nvSpPr>
+        <p:spPr>
+          <a:xfrm>
+            <a:off x="594360" y="320040"/>
+            <a:ext cx="3931920" cy="502920"/>
           </a:xfrm>
           <a:prstGeom prst="rect">
             <a:avLst/>
           </a:prstGeom>
-        </p:spPr>
-      </p:pic>
+          <a:noFill/>
+        </p:spPr>
+        <p:txBody>
+          <a:bodyPr wrap="square" lIns="36576" rIns="36576" tIns="27432" bIns="27432">
+            <a:noAutofit/>
+          </a:bodyPr>
+          <a:lstStyle/>
+          <a:p>
+            <a:pPr algn="l">
+              <a:spcAft>
+                <a:spcPts val="0"/>
+              </a:spcAft>
+            </a:pPr>
+            <a:r>
+              <a:rPr sz="2800" b="1">
+                <a:solidFill>
+                  <a:srgbClr val="26384A"/>
+                </a:solidFill>
+                <a:latin typeface="PingFang SC"/>
+                <a:ea typeface="PingFang SC"/>
+              </a:rPr>
+              <a:t>小小新闻</a:t>
+            </a:r>
+          </a:p>
+        </p:txBody>
+      </p:sp>
       <p:sp>
         <p:nvSpPr>
           <p:cNvPr id="4" name="Rounded Rectangle 3"/>
@@ -3948,14 +3995,14 @@
         </p:nvSpPr>
         <p:spPr>
           <a:xfrm>
-            <a:off x="4882896" y="347472"/>
-            <a:ext cx="1737360" cy="621792"/>
+            <a:off x="7452360" y="310896"/>
+            <a:ext cx="4114800" cy="475488"/>
           </a:xfrm>
           <a:prstGeom prst="roundRect">
             <a:avLst/>
           </a:prstGeom>
           <a:solidFill>
-            <a:srgbClr val="FFD75E"/>
+            <a:srgbClr val="FFFFFF"/>
           </a:solidFill>
           <a:ln>
             <a:noFill/>
@@ -3992,8 +4039,8 @@
         </p:nvSpPr>
         <p:spPr>
           <a:xfrm>
-            <a:off x="5029200" y="512064"/>
-            <a:ext cx="1444752" cy="274320"/>
+            <a:off x="7616952" y="420624"/>
+            <a:ext cx="3794760" cy="210312"/>
           </a:xfrm>
           <a:prstGeom prst="rect">
             <a:avLst/>
@@ -4012,196 +4059,59 @@
               </a:spcAft>
             </a:pPr>
             <a:r>
-              <a:rPr sz="1700" b="1">
+              <a:rPr sz="1200" b="1">
                 <a:solidFill>
                   <a:srgbClr val="26384A"/>
                 </a:solidFill>
                 <a:latin typeface="PingFang SC"/>
                 <a:ea typeface="PingFang SC"/>
               </a:rPr>
-              <a:t>到新家啦！</a:t>
-            </a:r>
-          </a:p>
-        </p:txBody>
-      </p:sp>
-      <p:sp>
-        <p:nvSpPr>
-          <p:cNvPr id="6" name="TextBox 5"/>
-          <p:cNvSpPr txBox="1"/>
+              <a:t>9月28日 星期一　上海 小雨 23—25℃</a:t>
+            </a:r>
+          </a:p>
+        </p:txBody>
+      </p:sp>
+      <p:pic>
+        <p:nvPicPr>
+          <p:cNvPr id="6" name="Picture 5" descr="tide.jpg"/>
+          <p:cNvPicPr>
+            <a:picLocks noChangeAspect="1"/>
+          </p:cNvPicPr>
           <p:nvPr/>
-        </p:nvSpPr>
-        <p:spPr>
-          <a:xfrm>
-            <a:off x="6812280" y="594360"/>
-            <a:ext cx="4297680" cy="365760"/>
+        </p:nvPicPr>
+        <p:blipFill>
+          <a:blip r:embed="rId2"/>
+          <a:srcRect l="2818" r="2818"/>
+          <a:stretch>
+            <a:fillRect/>
+          </a:stretch>
+        </p:blipFill>
+        <p:spPr>
+          <a:xfrm>
+            <a:off x="594360" y="1170432"/>
+            <a:ext cx="6675120" cy="4709160"/>
           </a:xfrm>
           <a:prstGeom prst="rect">
             <a:avLst/>
           </a:prstGeom>
-          <a:noFill/>
-        </p:spPr>
-        <p:txBody>
-          <a:bodyPr wrap="square" lIns="36576" rIns="36576" tIns="27432" bIns="27432">
-            <a:noAutofit/>
-          </a:bodyPr>
-          <a:lstStyle/>
-          <a:p>
-            <a:pPr algn="l">
-              <a:spcAft>
-                <a:spcPts val="0"/>
-              </a:spcAft>
-            </a:pPr>
-            <a:r>
-              <a:rPr sz="1400" b="1">
-                <a:solidFill>
-                  <a:srgbClr val="FF6475"/>
-                </a:solidFill>
-                <a:latin typeface="PingFang SC"/>
-                <a:ea typeface="PingFang SC"/>
-              </a:rPr>
-              <a:t>今天的新鲜事</a:t>
-            </a:r>
-          </a:p>
-        </p:txBody>
-      </p:sp>
-      <p:sp>
-        <p:nvSpPr>
-          <p:cNvPr id="7" name="TextBox 6"/>
-          <p:cNvSpPr txBox="1"/>
-          <p:nvPr/>
-        </p:nvSpPr>
-        <p:spPr>
-          <a:xfrm>
-            <a:off x="6748272" y="1060704"/>
-            <a:ext cx="4617720" cy="804672"/>
-          </a:xfrm>
-          <a:prstGeom prst="rect">
-            <a:avLst/>
-          </a:prstGeom>
-          <a:noFill/>
-        </p:spPr>
-        <p:txBody>
-          <a:bodyPr wrap="square" lIns="36576" rIns="36576" tIns="27432" bIns="27432">
-            <a:noAutofit/>
-          </a:bodyPr>
-          <a:lstStyle/>
-          <a:p>
-            <a:pPr algn="l">
-              <a:spcAft>
-                <a:spcPts val="0"/>
-              </a:spcAft>
-            </a:pPr>
-            <a:r>
-              <a:rPr sz="3400" b="1">
-                <a:solidFill>
-                  <a:srgbClr val="26384A"/>
-                </a:solidFill>
-                <a:latin typeface="PingFang SC"/>
-                <a:ea typeface="PingFang SC"/>
-              </a:rPr>
-              <a:t>熊猫坐飞机</a:t>
-            </a:r>
-          </a:p>
-        </p:txBody>
-      </p:sp>
-      <p:sp>
-        <p:nvSpPr>
-          <p:cNvPr id="8" name="TextBox 7"/>
-          <p:cNvSpPr txBox="1"/>
-          <p:nvPr/>
-        </p:nvSpPr>
-        <p:spPr>
-          <a:xfrm>
-            <a:off x="6784848" y="2084831"/>
-            <a:ext cx="4389120" cy="1234440"/>
-          </a:xfrm>
-          <a:prstGeom prst="rect">
-            <a:avLst/>
-          </a:prstGeom>
-          <a:noFill/>
-        </p:spPr>
-        <p:txBody>
-          <a:bodyPr wrap="square" lIns="36576" rIns="36576" tIns="27432" bIns="27432">
-            <a:noAutofit/>
-          </a:bodyPr>
-          <a:lstStyle/>
-          <a:p>
-            <a:pPr algn="l">
-              <a:spcAft>
-                <a:spcPts val="0"/>
-              </a:spcAft>
-            </a:pPr>
-            <a:r>
-              <a:rPr sz="2700" b="1">
-                <a:solidFill>
-                  <a:srgbClr val="26384A"/>
-                </a:solidFill>
-                <a:latin typeface="PingFang SC"/>
-                <a:ea typeface="PingFang SC"/>
-              </a:rPr>
-              <a:t>平平和福双
-到了新家。</a:t>
-            </a:r>
-          </a:p>
-        </p:txBody>
-      </p:sp>
-      <p:sp>
-        <p:nvSpPr>
-          <p:cNvPr id="9" name="TextBox 8"/>
-          <p:cNvSpPr txBox="1"/>
-          <p:nvPr/>
-        </p:nvSpPr>
-        <p:spPr>
-          <a:xfrm>
-            <a:off x="6784848" y="3584448"/>
-            <a:ext cx="4389120" cy="1143000"/>
-          </a:xfrm>
-          <a:prstGeom prst="rect">
-            <a:avLst/>
-          </a:prstGeom>
-          <a:noFill/>
-        </p:spPr>
-        <p:txBody>
-          <a:bodyPr wrap="square" lIns="36576" rIns="36576" tIns="27432" bIns="27432">
-            <a:noAutofit/>
-          </a:bodyPr>
-          <a:lstStyle/>
-          <a:p>
-            <a:pPr algn="l">
-              <a:spcAft>
-                <a:spcPts val="0"/>
-              </a:spcAft>
-            </a:pPr>
-            <a:r>
-              <a:rPr sz="2300" b="0">
-                <a:solidFill>
-                  <a:srgbClr val="26384A"/>
-                </a:solidFill>
-                <a:latin typeface="PingFang SC"/>
-                <a:ea typeface="PingFang SC"/>
-              </a:rPr>
-              <a:t>它们先休息，
-过些天再见大家。</a:t>
-            </a:r>
-          </a:p>
-        </p:txBody>
-      </p:sp>
-      <p:sp>
-        <p:nvSpPr>
-          <p:cNvPr id="10" name="Rounded Rectangle 9"/>
+        </p:spPr>
+      </p:pic>
+      <p:sp>
+        <p:nvSpPr>
+          <p:cNvPr id="7" name="Rounded Rectangle 6"/>
           <p:cNvSpPr/>
           <p:nvPr/>
         </p:nvSpPr>
         <p:spPr>
           <a:xfrm>
-            <a:off x="6784848" y="4965192"/>
-            <a:ext cx="4069080" cy="713232"/>
+            <a:off x="804672" y="1389888"/>
+            <a:ext cx="530352" cy="530352"/>
           </a:xfrm>
           <a:prstGeom prst="roundRect">
             <a:avLst/>
           </a:prstGeom>
           <a:solidFill>
-            <a:srgbClr val="FFFFFF"/>
+            <a:srgbClr val="FFD75E"/>
           </a:solidFill>
           <a:ln>
             <a:noFill/>
@@ -4232,14 +4142,14 @@
       </p:sp>
       <p:sp>
         <p:nvSpPr>
-          <p:cNvPr id="11" name="TextBox 10"/>
+          <p:cNvPr id="8" name="TextBox 7"/>
           <p:cNvSpPr txBox="1"/>
           <p:nvPr/>
         </p:nvSpPr>
         <p:spPr>
           <a:xfrm>
-            <a:off x="6986016" y="5148072"/>
-            <a:ext cx="3703320" cy="292608"/>
+            <a:off x="804672" y="1527048"/>
+            <a:ext cx="530352" cy="219456"/>
           </a:xfrm>
           <a:prstGeom prst="rect">
             <a:avLst/>
@@ -4252,34 +4162,34 @@
           </a:bodyPr>
           <a:lstStyle/>
           <a:p>
-            <a:pPr algn="l">
+            <a:pPr algn="ctr">
               <a:spcAft>
                 <a:spcPts val="0"/>
               </a:spcAft>
             </a:pPr>
             <a:r>
-              <a:rPr sz="1800" b="1">
+              <a:rPr sz="1600" b="1">
                 <a:solidFill>
                   <a:srgbClr val="26384A"/>
                 </a:solidFill>
                 <a:latin typeface="PingFang SC"/>
                 <a:ea typeface="PingFang SC"/>
               </a:rPr>
-              <a:t>你想送熊猫什么礼物？</a:t>
-            </a:r>
-          </a:p>
-        </p:txBody>
-      </p:sp>
-      <p:sp>
-        <p:nvSpPr>
-          <p:cNvPr id="12" name="TextBox 11"/>
+              <a:t>3</a:t>
+            </a:r>
+          </a:p>
+        </p:txBody>
+      </p:sp>
+      <p:sp>
+        <p:nvSpPr>
+          <p:cNvPr id="9" name="TextBox 8"/>
           <p:cNvSpPr txBox="1"/>
           <p:nvPr/>
         </p:nvSpPr>
         <p:spPr>
           <a:xfrm>
-            <a:off x="621792" y="5806440"/>
-            <a:ext cx="7772400" cy="228600"/>
+            <a:off x="7699248" y="1508760"/>
+            <a:ext cx="3749039" cy="713232"/>
           </a:xfrm>
           <a:prstGeom prst="rect">
             <a:avLst/>
@@ -4298,28 +4208,28 @@
               </a:spcAft>
             </a:pPr>
             <a:r>
-              <a:rPr sz="900" b="0">
+              <a:rPr sz="3200" b="1">
                 <a:solidFill>
-                  <a:srgbClr val="607080"/>
+                  <a:srgbClr val="26384A"/>
                 </a:solidFill>
                 <a:latin typeface="PingFang SC"/>
                 <a:ea typeface="PingFang SC"/>
               </a:rPr>
-              <a:t>新闻：新华社 2026年9月28日　图片：央视新闻</a:t>
-            </a:r>
-          </a:p>
-        </p:txBody>
-      </p:sp>
-      <p:sp>
-        <p:nvSpPr>
-          <p:cNvPr id="13" name="TextBox 12"/>
+              <a:t>潮水像蝴蝶</a:t>
+            </a:r>
+          </a:p>
+        </p:txBody>
+      </p:sp>
+      <p:sp>
+        <p:nvSpPr>
+          <p:cNvPr id="10" name="TextBox 9"/>
           <p:cNvSpPr txBox="1"/>
           <p:nvPr/>
         </p:nvSpPr>
         <p:spPr>
           <a:xfrm>
-            <a:off x="621792" y="6236208"/>
-            <a:ext cx="7955279" cy="274320"/>
+            <a:off x="7699248" y="2560320"/>
+            <a:ext cx="3749039" cy="1143000"/>
           </a:xfrm>
           <a:prstGeom prst="rect">
             <a:avLst/>
@@ -4338,14 +4248,139 @@
               </a:spcAft>
             </a:pPr>
             <a:r>
-              <a:rPr sz="1200" b="1">
+              <a:rPr sz="2400" b="0">
                 <a:solidFill>
-                  <a:srgbClr val="607080"/>
+                  <a:srgbClr val="26384A"/>
                 </a:solidFill>
                 <a:latin typeface="PingFang SC"/>
                 <a:ea typeface="PingFang SC"/>
               </a:rPr>
-              <a:t>我的分享说完了，谢谢大家！</a:t>
+              <a:t>三股潮水碰在一起，
+像一只大大的蝴蝶。</a:t>
+            </a:r>
+          </a:p>
+        </p:txBody>
+      </p:sp>
+      <p:sp>
+        <p:nvSpPr>
+          <p:cNvPr id="11" name="Rounded Rectangle 10"/>
+          <p:cNvSpPr/>
+          <p:nvPr/>
+        </p:nvSpPr>
+        <p:spPr>
+          <a:xfrm>
+            <a:off x="7699248" y="4114800"/>
+            <a:ext cx="3794760" cy="749808"/>
+          </a:xfrm>
+          <a:prstGeom prst="roundRect">
+            <a:avLst/>
+          </a:prstGeom>
+          <a:solidFill>
+            <a:srgbClr val="FFFFFF"/>
+          </a:solidFill>
+          <a:ln>
+            <a:noFill/>
+          </a:ln>
+          <a:effectLst/>
+        </p:spPr>
+        <p:style>
+          <a:lnRef idx="1">
+            <a:schemeClr val="accent1"/>
+          </a:lnRef>
+          <a:fillRef idx="3">
+            <a:schemeClr val="accent1"/>
+          </a:fillRef>
+          <a:effectRef idx="2">
+            <a:schemeClr val="accent1"/>
+          </a:effectRef>
+          <a:fontRef idx="minor">
+            <a:schemeClr val="lt1"/>
+          </a:fontRef>
+        </p:style>
+        <p:txBody>
+          <a:bodyPr rtlCol="0" anchor="ctr"/>
+          <a:lstStyle/>
+          <a:p>
+            <a:pPr algn="ctr"/>
+          </a:p>
+        </p:txBody>
+      </p:sp>
+      <p:sp>
+        <p:nvSpPr>
+          <p:cNvPr id="12" name="TextBox 11"/>
+          <p:cNvSpPr txBox="1"/>
+          <p:nvPr/>
+        </p:nvSpPr>
+        <p:spPr>
+          <a:xfrm>
+            <a:off x="7900416" y="4315968"/>
+            <a:ext cx="3401568" cy="292608"/>
+          </a:xfrm>
+          <a:prstGeom prst="rect">
+            <a:avLst/>
+          </a:prstGeom>
+          <a:noFill/>
+        </p:spPr>
+        <p:txBody>
+          <a:bodyPr wrap="square" lIns="36576" rIns="36576" tIns="27432" bIns="27432">
+            <a:noAutofit/>
+          </a:bodyPr>
+          <a:lstStyle/>
+          <a:p>
+            <a:pPr algn="l">
+              <a:spcAft>
+                <a:spcPts val="0"/>
+              </a:spcAft>
+            </a:pPr>
+            <a:r>
+              <a:rPr sz="1800" b="1">
+                <a:solidFill>
+                  <a:srgbClr val="FF6475"/>
+                </a:solidFill>
+                <a:latin typeface="PingFang SC"/>
+                <a:ea typeface="PingFang SC"/>
+              </a:rPr>
+              <a:t>你觉得它还像什么？</a:t>
+            </a:r>
+          </a:p>
+        </p:txBody>
+      </p:sp>
+      <p:sp>
+        <p:nvSpPr>
+          <p:cNvPr id="13" name="TextBox 12"/>
+          <p:cNvSpPr txBox="1"/>
+          <p:nvPr/>
+        </p:nvSpPr>
+        <p:spPr>
+          <a:xfrm>
+            <a:off x="7699248" y="5257800"/>
+            <a:ext cx="3657600" cy="548640"/>
+          </a:xfrm>
+          <a:prstGeom prst="rect">
+            <a:avLst/>
+          </a:prstGeom>
+          <a:noFill/>
+        </p:spPr>
+        <p:txBody>
+          <a:bodyPr wrap="square" lIns="36576" rIns="36576" tIns="27432" bIns="27432">
+            <a:noAutofit/>
+          </a:bodyPr>
+          <a:lstStyle/>
+          <a:p>
+            <a:pPr algn="l">
+              <a:spcAft>
+                <a:spcPts val="0"/>
+              </a:spcAft>
+            </a:pPr>
+            <a:r>
+              <a:rPr sz="1500" b="1">
+                <a:solidFill>
+                  <a:srgbClr val="617080"/>
+                </a:solidFill>
+                <a:latin typeface="PingFang SC"/>
+                <a:ea typeface="PingFang SC"/>
+              </a:rPr>
+              <a:t>选一条你最喜欢的新闻讲给大家听。</a:t>
             </a:r>
           </a:p>
         </p:txBody>
@@ -4358,8 +4393,48 @@
         </p:nvSpPr>
         <p:spPr>
           <a:xfrm>
-            <a:off x="10698480" y="6236208"/>
-            <a:ext cx="640080" cy="274320"/>
+            <a:off x="594360" y="6446520"/>
+            <a:ext cx="8961120" cy="182880"/>
+          </a:xfrm>
+          <a:prstGeom prst="rect">
+            <a:avLst/>
+          </a:prstGeom>
+          <a:noFill/>
+        </p:spPr>
+        <p:txBody>
+          <a:bodyPr wrap="square" lIns="36576" rIns="36576" tIns="27432" bIns="27432">
+            <a:noAutofit/>
+          </a:bodyPr>
+          <a:lstStyle/>
+          <a:p>
+            <a:pPr algn="l">
+              <a:spcAft>
+                <a:spcPts val="0"/>
+              </a:spcAft>
+            </a:pPr>
+            <a:r>
+              <a:rPr sz="800" b="0">
+                <a:solidFill>
+                  <a:srgbClr val="617080"/>
+                </a:solidFill>
+                <a:latin typeface="PingFang SC"/>
+                <a:ea typeface="PingFang SC"/>
+              </a:rPr>
+              <a:t>新闻与图片：中新网 · 2026年9月27日</a:t>
+            </a:r>
+          </a:p>
+        </p:txBody>
+      </p:sp>
+      <p:sp>
+        <p:nvSpPr>
+          <p:cNvPr id="15" name="TextBox 14"/>
+          <p:cNvSpPr txBox="1"/>
+          <p:nvPr/>
+        </p:nvSpPr>
+        <p:spPr>
+          <a:xfrm>
+            <a:off x="10744200" y="6419088"/>
+            <a:ext cx="594360" cy="201168"/>
           </a:xfrm>
           <a:prstGeom prst="rect">
             <a:avLst/>
@@ -4378,9 +4453,9 @@
               </a:spcAft>
             </a:pPr>
             <a:r>
-              <a:rPr sz="1100" b="1">
+              <a:rPr sz="900" b="1">
                 <a:solidFill>
-                  <a:srgbClr val="607080"/>
+                  <a:srgbClr val="617080"/>
                 </a:solidFill>
                 <a:latin typeface="PingFang SC"/>
                 <a:ea typeface="PingFang SC"/>

</xml_diff>

<commit_message>
Clarify the science and tide stories
Connect each image to its child-friendly takeaway and replace the conference photo with the actual three-tide meeting scene.
</commit_message>
<xml_diff>
--- a/daily-news/2026-09-28/今日新闻-2026-09-28.pptx
+++ b/daily-news/2026-09-28/今日新闻-2026-09-28.pptx
@@ -3412,141 +3412,20 @@
       </p:sp>
       <p:sp>
         <p:nvSpPr>
-          <p:cNvPr id="10" name="TextBox 9"/>
-          <p:cNvSpPr txBox="1"/>
-          <p:nvPr/>
-        </p:nvSpPr>
-        <p:spPr>
-          <a:xfrm>
-            <a:off x="822960" y="3977639"/>
-            <a:ext cx="4754880" cy="457200"/>
-          </a:xfrm>
-          <a:prstGeom prst="rect">
-            <a:avLst/>
-          </a:prstGeom>
-          <a:noFill/>
-        </p:spPr>
-        <p:txBody>
-          <a:bodyPr wrap="square" lIns="36576" rIns="36576" tIns="27432" bIns="27432">
-            <a:noAutofit/>
-          </a:bodyPr>
-          <a:lstStyle/>
-          <a:p>
-            <a:pPr algn="l">
-              <a:spcAft>
-                <a:spcPts val="0"/>
-              </a:spcAft>
-            </a:pPr>
-            <a:r>
-              <a:rPr sz="2500" b="1">
-                <a:solidFill>
-                  <a:srgbClr val="26384A"/>
-                </a:solidFill>
-                <a:latin typeface="PingFang SC"/>
-                <a:ea typeface="PingFang SC"/>
-              </a:rPr>
-              <a:t>熊猫坐飞机</a:t>
-            </a:r>
-          </a:p>
-        </p:txBody>
-      </p:sp>
-      <p:sp>
-        <p:nvSpPr>
-          <p:cNvPr id="11" name="TextBox 10"/>
-          <p:cNvSpPr txBox="1"/>
-          <p:nvPr/>
-        </p:nvSpPr>
-        <p:spPr>
-          <a:xfrm>
-            <a:off x="822960" y="4507992"/>
-            <a:ext cx="4754880" cy="640080"/>
-          </a:xfrm>
-          <a:prstGeom prst="rect">
-            <a:avLst/>
-          </a:prstGeom>
-          <a:noFill/>
-        </p:spPr>
-        <p:txBody>
-          <a:bodyPr wrap="square" lIns="36576" rIns="36576" tIns="27432" bIns="27432">
-            <a:noAutofit/>
-          </a:bodyPr>
-          <a:lstStyle/>
-          <a:p>
-            <a:pPr algn="l">
-              <a:spcAft>
-                <a:spcPts val="0"/>
-              </a:spcAft>
-            </a:pPr>
-            <a:r>
-              <a:rPr sz="1900" b="0">
-                <a:solidFill>
-                  <a:srgbClr val="26384A"/>
-                </a:solidFill>
-                <a:latin typeface="PingFang SC"/>
-                <a:ea typeface="PingFang SC"/>
-              </a:rPr>
-              <a:t>平平和福双到了新家。
-它们先要好好休息。</a:t>
-            </a:r>
-          </a:p>
-        </p:txBody>
-      </p:sp>
-      <p:sp>
-        <p:nvSpPr>
-          <p:cNvPr id="12" name="TextBox 11"/>
-          <p:cNvSpPr txBox="1"/>
-          <p:nvPr/>
-        </p:nvSpPr>
-        <p:spPr>
-          <a:xfrm>
-            <a:off x="822960" y="5367528"/>
-            <a:ext cx="4754880" cy="320040"/>
-          </a:xfrm>
-          <a:prstGeom prst="rect">
-            <a:avLst/>
-          </a:prstGeom>
-          <a:noFill/>
-        </p:spPr>
-        <p:txBody>
-          <a:bodyPr wrap="square" lIns="36576" rIns="36576" tIns="27432" bIns="27432">
-            <a:noAutofit/>
-          </a:bodyPr>
-          <a:lstStyle/>
-          <a:p>
-            <a:pPr algn="l">
-              <a:spcAft>
-                <a:spcPts val="0"/>
-              </a:spcAft>
-            </a:pPr>
-            <a:r>
-              <a:rPr sz="1600" b="1">
-                <a:solidFill>
-                  <a:srgbClr val="FF6475"/>
-                </a:solidFill>
-                <a:latin typeface="PingFang SC"/>
-                <a:ea typeface="PingFang SC"/>
-              </a:rPr>
-              <a:t>你想送熊猫什么礼物？</a:t>
-            </a:r>
-          </a:p>
-        </p:txBody>
-      </p:sp>
-      <p:sp>
-        <p:nvSpPr>
-          <p:cNvPr id="13" name="Rounded Rectangle 12"/>
+          <p:cNvPr id="10" name="Rounded Rectangle 9"/>
           <p:cNvSpPr/>
           <p:nvPr/>
         </p:nvSpPr>
         <p:spPr>
           <a:xfrm>
-            <a:off x="6309360" y="1143000"/>
-            <a:ext cx="5303520" cy="4983480"/>
+            <a:off x="914400" y="3337560"/>
+            <a:ext cx="4617720" cy="347472"/>
           </a:xfrm>
           <a:prstGeom prst="roundRect">
             <a:avLst/>
           </a:prstGeom>
           <a:solidFill>
-            <a:srgbClr val="EAF5FF"/>
+            <a:srgbClr val="26384A"/>
           </a:solidFill>
           <a:ln>
             <a:noFill/>
@@ -3575,31 +3454,167 @@
           </a:p>
         </p:txBody>
       </p:sp>
-      <p:pic>
-        <p:nvPicPr>
-          <p:cNvPr id="14" name="Picture 13" descr="science-letters.jpg"/>
-          <p:cNvPicPr>
-            <a:picLocks noChangeAspect="1"/>
-          </p:cNvPicPr>
+      <p:sp>
+        <p:nvSpPr>
+          <p:cNvPr id="11" name="TextBox 10"/>
+          <p:cNvSpPr txBox="1"/>
           <p:nvPr/>
-        </p:nvPicPr>
-        <p:blipFill>
-          <a:blip r:embed="rId3"/>
-          <a:srcRect t="10917" b="10917"/>
-          <a:stretch>
-            <a:fillRect/>
-          </a:stretch>
-        </p:blipFill>
-        <p:spPr>
-          <a:xfrm>
-            <a:off x="6455664" y="1298448"/>
-            <a:ext cx="5010912" cy="2487168"/>
+        </p:nvSpPr>
+        <p:spPr>
+          <a:xfrm>
+            <a:off x="1024128" y="3419856"/>
+            <a:ext cx="4389120" cy="164592"/>
           </a:xfrm>
           <a:prstGeom prst="rect">
             <a:avLst/>
           </a:prstGeom>
-        </p:spPr>
-      </p:pic>
+          <a:noFill/>
+        </p:spPr>
+        <p:txBody>
+          <a:bodyPr wrap="square" lIns="36576" rIns="36576" tIns="27432" bIns="27432">
+            <a:noAutofit/>
+          </a:bodyPr>
+          <a:lstStyle/>
+          <a:p>
+            <a:pPr algn="ctr">
+              <a:spcAft>
+                <a:spcPts val="0"/>
+              </a:spcAft>
+            </a:pPr>
+            <a:r>
+              <a:rPr sz="1000" b="1">
+                <a:solidFill>
+                  <a:srgbClr val="FFFFFF"/>
+                </a:solidFill>
+                <a:latin typeface="PingFang SC"/>
+                <a:ea typeface="PingFang SC"/>
+              </a:rPr>
+              <a:t>图里：熊猫的新家</a:t>
+            </a:r>
+          </a:p>
+        </p:txBody>
+      </p:sp>
+      <p:sp>
+        <p:nvSpPr>
+          <p:cNvPr id="12" name="TextBox 11"/>
+          <p:cNvSpPr txBox="1"/>
+          <p:nvPr/>
+        </p:nvSpPr>
+        <p:spPr>
+          <a:xfrm>
+            <a:off x="822960" y="3977639"/>
+            <a:ext cx="4754880" cy="457200"/>
+          </a:xfrm>
+          <a:prstGeom prst="rect">
+            <a:avLst/>
+          </a:prstGeom>
+          <a:noFill/>
+        </p:spPr>
+        <p:txBody>
+          <a:bodyPr wrap="square" lIns="36576" rIns="36576" tIns="27432" bIns="27432">
+            <a:noAutofit/>
+          </a:bodyPr>
+          <a:lstStyle/>
+          <a:p>
+            <a:pPr algn="l">
+              <a:spcAft>
+                <a:spcPts val="0"/>
+              </a:spcAft>
+            </a:pPr>
+            <a:r>
+              <a:rPr sz="2500" b="1">
+                <a:solidFill>
+                  <a:srgbClr val="26384A"/>
+                </a:solidFill>
+                <a:latin typeface="PingFang SC"/>
+                <a:ea typeface="PingFang SC"/>
+              </a:rPr>
+              <a:t>熊猫坐飞机</a:t>
+            </a:r>
+          </a:p>
+        </p:txBody>
+      </p:sp>
+      <p:sp>
+        <p:nvSpPr>
+          <p:cNvPr id="13" name="TextBox 12"/>
+          <p:cNvSpPr txBox="1"/>
+          <p:nvPr/>
+        </p:nvSpPr>
+        <p:spPr>
+          <a:xfrm>
+            <a:off x="822960" y="4507992"/>
+            <a:ext cx="4754880" cy="640080"/>
+          </a:xfrm>
+          <a:prstGeom prst="rect">
+            <a:avLst/>
+          </a:prstGeom>
+          <a:noFill/>
+        </p:spPr>
+        <p:txBody>
+          <a:bodyPr wrap="square" lIns="36576" rIns="36576" tIns="27432" bIns="27432">
+            <a:noAutofit/>
+          </a:bodyPr>
+          <a:lstStyle/>
+          <a:p>
+            <a:pPr algn="l">
+              <a:spcAft>
+                <a:spcPts val="0"/>
+              </a:spcAft>
+            </a:pPr>
+            <a:r>
+              <a:rPr sz="1900" b="0">
+                <a:solidFill>
+                  <a:srgbClr val="26384A"/>
+                </a:solidFill>
+                <a:latin typeface="PingFang SC"/>
+                <a:ea typeface="PingFang SC"/>
+              </a:rPr>
+              <a:t>平平和福双到了新家。
+它们先要好好休息。</a:t>
+            </a:r>
+          </a:p>
+        </p:txBody>
+      </p:sp>
+      <p:sp>
+        <p:nvSpPr>
+          <p:cNvPr id="14" name="TextBox 13"/>
+          <p:cNvSpPr txBox="1"/>
+          <p:nvPr/>
+        </p:nvSpPr>
+        <p:spPr>
+          <a:xfrm>
+            <a:off x="822960" y="5367528"/>
+            <a:ext cx="4754880" cy="320040"/>
+          </a:xfrm>
+          <a:prstGeom prst="rect">
+            <a:avLst/>
+          </a:prstGeom>
+          <a:noFill/>
+        </p:spPr>
+        <p:txBody>
+          <a:bodyPr wrap="square" lIns="36576" rIns="36576" tIns="27432" bIns="27432">
+            <a:noAutofit/>
+          </a:bodyPr>
+          <a:lstStyle/>
+          <a:p>
+            <a:pPr algn="l">
+              <a:spcAft>
+                <a:spcPts val="0"/>
+              </a:spcAft>
+            </a:pPr>
+            <a:r>
+              <a:rPr sz="1600" b="1">
+                <a:solidFill>
+                  <a:srgbClr val="FF6475"/>
+                </a:solidFill>
+                <a:latin typeface="PingFang SC"/>
+                <a:ea typeface="PingFang SC"/>
+              </a:rPr>
+              <a:t>你想送熊猫什么礼物？</a:t>
+            </a:r>
+          </a:p>
+        </p:txBody>
+      </p:sp>
       <p:sp>
         <p:nvSpPr>
           <p:cNvPr id="15" name="Rounded Rectangle 14"/>
@@ -3608,14 +3623,14 @@
         </p:nvSpPr>
         <p:spPr>
           <a:xfrm>
-            <a:off x="6601968" y="1444752"/>
-            <a:ext cx="502920" cy="502920"/>
+            <a:off x="6309360" y="1143000"/>
+            <a:ext cx="5303520" cy="4983480"/>
           </a:xfrm>
           <a:prstGeom prst="roundRect">
             <a:avLst/>
           </a:prstGeom>
           <a:solidFill>
-            <a:srgbClr val="FFD75E"/>
+            <a:srgbClr val="EAF5FF"/>
           </a:solidFill>
           <a:ln>
             <a:noFill/>
@@ -3644,9 +3659,78 @@
           </a:p>
         </p:txBody>
       </p:sp>
-      <p:sp>
-        <p:nvSpPr>
-          <p:cNvPr id="16" name="TextBox 15"/>
+      <p:pic>
+        <p:nvPicPr>
+          <p:cNvPr id="16" name="Picture 15" descr="science-letters.jpg"/>
+          <p:cNvPicPr>
+            <a:picLocks noChangeAspect="1"/>
+          </p:cNvPicPr>
+          <p:nvPr/>
+        </p:nvPicPr>
+        <p:blipFill>
+          <a:blip r:embed="rId3"/>
+          <a:srcRect t="10917" b="10917"/>
+          <a:stretch>
+            <a:fillRect/>
+          </a:stretch>
+        </p:blipFill>
+        <p:spPr>
+          <a:xfrm>
+            <a:off x="6455664" y="1298448"/>
+            <a:ext cx="5010912" cy="2487168"/>
+          </a:xfrm>
+          <a:prstGeom prst="rect">
+            <a:avLst/>
+          </a:prstGeom>
+        </p:spPr>
+      </p:pic>
+      <p:sp>
+        <p:nvSpPr>
+          <p:cNvPr id="17" name="Rounded Rectangle 16"/>
+          <p:cNvSpPr/>
+          <p:nvPr/>
+        </p:nvSpPr>
+        <p:spPr>
+          <a:xfrm>
+            <a:off x="6601968" y="1444752"/>
+            <a:ext cx="502920" cy="502920"/>
+          </a:xfrm>
+          <a:prstGeom prst="roundRect">
+            <a:avLst/>
+          </a:prstGeom>
+          <a:solidFill>
+            <a:srgbClr val="FFD75E"/>
+          </a:solidFill>
+          <a:ln>
+            <a:noFill/>
+          </a:ln>
+          <a:effectLst/>
+        </p:spPr>
+        <p:style>
+          <a:lnRef idx="1">
+            <a:schemeClr val="accent1"/>
+          </a:lnRef>
+          <a:fillRef idx="3">
+            <a:schemeClr val="accent1"/>
+          </a:fillRef>
+          <a:effectRef idx="2">
+            <a:schemeClr val="accent1"/>
+          </a:effectRef>
+          <a:fontRef idx="minor">
+            <a:schemeClr val="lt1"/>
+          </a:fontRef>
+        </p:style>
+        <p:txBody>
+          <a:bodyPr rtlCol="0" anchor="ctr"/>
+          <a:lstStyle/>
+          <a:p>
+            <a:pPr algn="ctr"/>
+          </a:p>
+        </p:txBody>
+      </p:sp>
+      <p:sp>
+        <p:nvSpPr>
+          <p:cNvPr id="18" name="TextBox 17"/>
           <p:cNvSpPr txBox="1"/>
           <p:nvPr/>
         </p:nvSpPr>
@@ -3686,7 +3770,91 @@
       </p:sp>
       <p:sp>
         <p:nvSpPr>
-          <p:cNvPr id="17" name="TextBox 16"/>
+          <p:cNvPr id="19" name="Rounded Rectangle 18"/>
+          <p:cNvSpPr/>
+          <p:nvPr/>
+        </p:nvSpPr>
+        <p:spPr>
+          <a:xfrm>
+            <a:off x="6656832" y="3337560"/>
+            <a:ext cx="4617720" cy="347472"/>
+          </a:xfrm>
+          <a:prstGeom prst="roundRect">
+            <a:avLst/>
+          </a:prstGeom>
+          <a:solidFill>
+            <a:srgbClr val="26384A"/>
+          </a:solidFill>
+          <a:ln>
+            <a:noFill/>
+          </a:ln>
+          <a:effectLst/>
+        </p:spPr>
+        <p:style>
+          <a:lnRef idx="1">
+            <a:schemeClr val="accent1"/>
+          </a:lnRef>
+          <a:fillRef idx="3">
+            <a:schemeClr val="accent1"/>
+          </a:fillRef>
+          <a:effectRef idx="2">
+            <a:schemeClr val="accent1"/>
+          </a:effectRef>
+          <a:fontRef idx="minor">
+            <a:schemeClr val="lt1"/>
+          </a:fontRef>
+        </p:style>
+        <p:txBody>
+          <a:bodyPr rtlCol="0" anchor="ctr"/>
+          <a:lstStyle/>
+          <a:p>
+            <a:pPr algn="ctr"/>
+          </a:p>
+        </p:txBody>
+      </p:sp>
+      <p:sp>
+        <p:nvSpPr>
+          <p:cNvPr id="20" name="TextBox 19"/>
+          <p:cNvSpPr txBox="1"/>
+          <p:nvPr/>
+        </p:nvSpPr>
+        <p:spPr>
+          <a:xfrm>
+            <a:off x="6766560" y="3419856"/>
+            <a:ext cx="4389120" cy="164592"/>
+          </a:xfrm>
+          <a:prstGeom prst="rect">
+            <a:avLst/>
+          </a:prstGeom>
+          <a:noFill/>
+        </p:spPr>
+        <p:txBody>
+          <a:bodyPr wrap="square" lIns="36576" rIns="36576" tIns="27432" bIns="27432">
+            <a:noAutofit/>
+          </a:bodyPr>
+          <a:lstStyle/>
+          <a:p>
+            <a:pPr algn="ctr">
+              <a:spcAft>
+                <a:spcPts val="0"/>
+              </a:spcAft>
+            </a:pPr>
+            <a:r>
+              <a:rPr sz="1000" b="1">
+                <a:solidFill>
+                  <a:srgbClr val="FFFFFF"/>
+                </a:solidFill>
+                <a:latin typeface="PingFang SC"/>
+                <a:ea typeface="PingFang SC"/>
+              </a:rPr>
+              <a:t>图里：科学家爷爷在海上研究海底</a:t>
+            </a:r>
+          </a:p>
+        </p:txBody>
+      </p:sp>
+      <p:sp>
+        <p:nvSpPr>
+          <p:cNvPr id="21" name="TextBox 20"/>
           <p:cNvSpPr txBox="1"/>
           <p:nvPr/>
         </p:nvSpPr>
@@ -3719,14 +3887,14 @@
                 <a:latin typeface="PingFang SC"/>
                 <a:ea typeface="PingFang SC"/>
               </a:rPr>
-              <a:t>一封科学来信</a:t>
-            </a:r>
-          </a:p>
-        </p:txBody>
-      </p:sp>
-      <p:sp>
-        <p:nvSpPr>
-          <p:cNvPr id="18" name="TextBox 17"/>
+              <a:t>科学家写来一封信</a:t>
+            </a:r>
+          </a:p>
+        </p:txBody>
+      </p:sp>
+      <p:sp>
+        <p:nvSpPr>
+          <p:cNvPr id="22" name="TextBox 21"/>
           <p:cNvSpPr txBox="1"/>
           <p:nvPr/>
         </p:nvSpPr>
@@ -3759,15 +3927,15 @@
                 <a:latin typeface="PingFang SC"/>
                 <a:ea typeface="PingFang SC"/>
               </a:rPr>
-              <a:t>科学家写信给小朋友：
-多问为什么，勇敢想一想。</a:t>
-            </a:r>
-          </a:p>
-        </p:txBody>
-      </p:sp>
-      <p:sp>
-        <p:nvSpPr>
-          <p:cNvPr id="19" name="TextBox 18"/>
+              <a:t>他想告诉小朋友：
+多问为什么，勇敢找答案。</a:t>
+            </a:r>
+          </a:p>
+        </p:txBody>
+      </p:sp>
+      <p:sp>
+        <p:nvSpPr>
+          <p:cNvPr id="23" name="TextBox 22"/>
           <p:cNvSpPr txBox="1"/>
           <p:nvPr/>
         </p:nvSpPr>
@@ -3800,14 +3968,14 @@
                 <a:latin typeface="PingFang SC"/>
                 <a:ea typeface="PingFang SC"/>
               </a:rPr>
-              <a:t>你最想问什么？</a:t>
-            </a:r>
-          </a:p>
-        </p:txBody>
-      </p:sp>
-      <p:sp>
-        <p:nvSpPr>
-          <p:cNvPr id="20" name="TextBox 19"/>
+              <a:t>你想问他什么？</a:t>
+            </a:r>
+          </a:p>
+        </p:txBody>
+      </p:sp>
+      <p:sp>
+        <p:nvSpPr>
+          <p:cNvPr id="24" name="TextBox 23"/>
           <p:cNvSpPr txBox="1"/>
           <p:nvPr/>
         </p:nvSpPr>
@@ -3847,7 +4015,7 @@
       </p:sp>
       <p:sp>
         <p:nvSpPr>
-          <p:cNvPr id="21" name="TextBox 20"/>
+          <p:cNvPr id="25" name="TextBox 24"/>
           <p:cNvSpPr txBox="1"/>
           <p:nvPr/>
         </p:nvSpPr>
@@ -4073,7 +4241,7 @@
       </p:sp>
       <p:pic>
         <p:nvPicPr>
-          <p:cNvPr id="6" name="Picture 5" descr="tide.jpg"/>
+          <p:cNvPr id="6" name="Picture 5" descr="tide-three-waves.jpg"/>
           <p:cNvPicPr>
             <a:picLocks noChangeAspect="1"/>
           </p:cNvPicPr>
@@ -4081,7 +4249,7 @@
         </p:nvPicPr>
         <p:blipFill>
           <a:blip r:embed="rId2"/>
-          <a:srcRect l="2818" r="2818"/>
+          <a:srcRect t="28013" b="28013"/>
           <a:stretch>
             <a:fillRect/>
           </a:stretch>
@@ -4182,101 +4350,20 @@
       </p:sp>
       <p:sp>
         <p:nvSpPr>
-          <p:cNvPr id="9" name="TextBox 8"/>
-          <p:cNvSpPr txBox="1"/>
-          <p:nvPr/>
-        </p:nvSpPr>
-        <p:spPr>
-          <a:xfrm>
-            <a:off x="7699248" y="1508760"/>
-            <a:ext cx="3749039" cy="713232"/>
-          </a:xfrm>
-          <a:prstGeom prst="rect">
-            <a:avLst/>
-          </a:prstGeom>
-          <a:noFill/>
-        </p:spPr>
-        <p:txBody>
-          <a:bodyPr wrap="square" lIns="36576" rIns="36576" tIns="27432" bIns="27432">
-            <a:noAutofit/>
-          </a:bodyPr>
-          <a:lstStyle/>
-          <a:p>
-            <a:pPr algn="l">
-              <a:spcAft>
-                <a:spcPts val="0"/>
-              </a:spcAft>
-            </a:pPr>
-            <a:r>
-              <a:rPr sz="3200" b="1">
-                <a:solidFill>
-                  <a:srgbClr val="26384A"/>
-                </a:solidFill>
-                <a:latin typeface="PingFang SC"/>
-                <a:ea typeface="PingFang SC"/>
-              </a:rPr>
-              <a:t>潮水像蝴蝶</a:t>
-            </a:r>
-          </a:p>
-        </p:txBody>
-      </p:sp>
-      <p:sp>
-        <p:nvSpPr>
-          <p:cNvPr id="10" name="TextBox 9"/>
-          <p:cNvSpPr txBox="1"/>
-          <p:nvPr/>
-        </p:nvSpPr>
-        <p:spPr>
-          <a:xfrm>
-            <a:off x="7699248" y="2560320"/>
-            <a:ext cx="3749039" cy="1143000"/>
-          </a:xfrm>
-          <a:prstGeom prst="rect">
-            <a:avLst/>
-          </a:prstGeom>
-          <a:noFill/>
-        </p:spPr>
-        <p:txBody>
-          <a:bodyPr wrap="square" lIns="36576" rIns="36576" tIns="27432" bIns="27432">
-            <a:noAutofit/>
-          </a:bodyPr>
-          <a:lstStyle/>
-          <a:p>
-            <a:pPr algn="l">
-              <a:spcAft>
-                <a:spcPts val="0"/>
-              </a:spcAft>
-            </a:pPr>
-            <a:r>
-              <a:rPr sz="2400" b="0">
-                <a:solidFill>
-                  <a:srgbClr val="26384A"/>
-                </a:solidFill>
-                <a:latin typeface="PingFang SC"/>
-                <a:ea typeface="PingFang SC"/>
-              </a:rPr>
-              <a:t>三股潮水碰在一起，
-像一只大大的蝴蝶。</a:t>
-            </a:r>
-          </a:p>
-        </p:txBody>
-      </p:sp>
-      <p:sp>
-        <p:nvSpPr>
-          <p:cNvPr id="11" name="Rounded Rectangle 10"/>
+          <p:cNvPr id="9" name="Rounded Rectangle 8"/>
           <p:cNvSpPr/>
           <p:nvPr/>
         </p:nvSpPr>
         <p:spPr>
           <a:xfrm>
-            <a:off x="7699248" y="4114800"/>
-            <a:ext cx="3794760" cy="749808"/>
+            <a:off x="932688" y="5230368"/>
+            <a:ext cx="5989320" cy="384048"/>
           </a:xfrm>
           <a:prstGeom prst="roundRect">
             <a:avLst/>
           </a:prstGeom>
           <a:solidFill>
-            <a:srgbClr val="FFFFFF"/>
+            <a:srgbClr val="26384A"/>
           </a:solidFill>
           <a:ln>
             <a:noFill/>
@@ -4307,7 +4394,172 @@
       </p:sp>
       <p:sp>
         <p:nvSpPr>
+          <p:cNvPr id="10" name="TextBox 9"/>
+          <p:cNvSpPr txBox="1"/>
+          <p:nvPr/>
+        </p:nvSpPr>
+        <p:spPr>
+          <a:xfrm>
+            <a:off x="1097280" y="5321808"/>
+            <a:ext cx="5669280" cy="182880"/>
+          </a:xfrm>
+          <a:prstGeom prst="rect">
+            <a:avLst/>
+          </a:prstGeom>
+          <a:noFill/>
+        </p:spPr>
+        <p:txBody>
+          <a:bodyPr wrap="square" lIns="36576" rIns="36576" tIns="27432" bIns="27432">
+            <a:noAutofit/>
+          </a:bodyPr>
+          <a:lstStyle/>
+          <a:p>
+            <a:pPr algn="ctr">
+              <a:spcAft>
+                <a:spcPts val="0"/>
+              </a:spcAft>
+            </a:pPr>
+            <a:r>
+              <a:rPr sz="1200" b="1">
+                <a:solidFill>
+                  <a:srgbClr val="FFFFFF"/>
+                </a:solidFill>
+                <a:latin typeface="PingFang SC"/>
+                <a:ea typeface="PingFang SC"/>
+              </a:rPr>
+              <a:t>图里：三条白色浪花正在碰到一起</a:t>
+            </a:r>
+          </a:p>
+        </p:txBody>
+      </p:sp>
+      <p:sp>
+        <p:nvSpPr>
+          <p:cNvPr id="11" name="TextBox 10"/>
+          <p:cNvSpPr txBox="1"/>
+          <p:nvPr/>
+        </p:nvSpPr>
+        <p:spPr>
+          <a:xfrm>
+            <a:off x="7699248" y="1508760"/>
+            <a:ext cx="3749039" cy="713232"/>
+          </a:xfrm>
+          <a:prstGeom prst="rect">
+            <a:avLst/>
+          </a:prstGeom>
+          <a:noFill/>
+        </p:spPr>
+        <p:txBody>
+          <a:bodyPr wrap="square" lIns="36576" rIns="36576" tIns="27432" bIns="27432">
+            <a:noAutofit/>
+          </a:bodyPr>
+          <a:lstStyle/>
+          <a:p>
+            <a:pPr algn="l">
+              <a:spcAft>
+                <a:spcPts val="0"/>
+              </a:spcAft>
+            </a:pPr>
+            <a:r>
+              <a:rPr sz="3200" b="1">
+                <a:solidFill>
+                  <a:srgbClr val="26384A"/>
+                </a:solidFill>
+                <a:latin typeface="PingFang SC"/>
+                <a:ea typeface="PingFang SC"/>
+              </a:rPr>
+              <a:t>三股潮水相遇</a:t>
+            </a:r>
+          </a:p>
+        </p:txBody>
+      </p:sp>
+      <p:sp>
+        <p:nvSpPr>
           <p:cNvPr id="12" name="TextBox 11"/>
+          <p:cNvSpPr txBox="1"/>
+          <p:nvPr/>
+        </p:nvSpPr>
+        <p:spPr>
+          <a:xfrm>
+            <a:off x="7699248" y="2560320"/>
+            <a:ext cx="3749039" cy="1143000"/>
+          </a:xfrm>
+          <a:prstGeom prst="rect">
+            <a:avLst/>
+          </a:prstGeom>
+          <a:noFill/>
+        </p:spPr>
+        <p:txBody>
+          <a:bodyPr wrap="square" lIns="36576" rIns="36576" tIns="27432" bIns="27432">
+            <a:noAutofit/>
+          </a:bodyPr>
+          <a:lstStyle/>
+          <a:p>
+            <a:pPr algn="l">
+              <a:spcAft>
+                <a:spcPts val="0"/>
+              </a:spcAft>
+            </a:pPr>
+            <a:r>
+              <a:rPr sz="2400" b="0">
+                <a:solidFill>
+                  <a:srgbClr val="26384A"/>
+                </a:solidFill>
+                <a:latin typeface="PingFang SC"/>
+                <a:ea typeface="PingFang SC"/>
+              </a:rPr>
+              <a:t>三条浪花碰在一起，
+像一只大大的蝴蝶。</a:t>
+            </a:r>
+          </a:p>
+        </p:txBody>
+      </p:sp>
+      <p:sp>
+        <p:nvSpPr>
+          <p:cNvPr id="13" name="Rounded Rectangle 12"/>
+          <p:cNvSpPr/>
+          <p:nvPr/>
+        </p:nvSpPr>
+        <p:spPr>
+          <a:xfrm>
+            <a:off x="7699248" y="4114800"/>
+            <a:ext cx="3794760" cy="749808"/>
+          </a:xfrm>
+          <a:prstGeom prst="roundRect">
+            <a:avLst/>
+          </a:prstGeom>
+          <a:solidFill>
+            <a:srgbClr val="FFFFFF"/>
+          </a:solidFill>
+          <a:ln>
+            <a:noFill/>
+          </a:ln>
+          <a:effectLst/>
+        </p:spPr>
+        <p:style>
+          <a:lnRef idx="1">
+            <a:schemeClr val="accent1"/>
+          </a:lnRef>
+          <a:fillRef idx="3">
+            <a:schemeClr val="accent1"/>
+          </a:fillRef>
+          <a:effectRef idx="2">
+            <a:schemeClr val="accent1"/>
+          </a:effectRef>
+          <a:fontRef idx="minor">
+            <a:schemeClr val="lt1"/>
+          </a:fontRef>
+        </p:style>
+        <p:txBody>
+          <a:bodyPr rtlCol="0" anchor="ctr"/>
+          <a:lstStyle/>
+          <a:p>
+            <a:pPr algn="ctr"/>
+          </a:p>
+        </p:txBody>
+      </p:sp>
+      <p:sp>
+        <p:nvSpPr>
+          <p:cNvPr id="14" name="TextBox 13"/>
           <p:cNvSpPr txBox="1"/>
           <p:nvPr/>
         </p:nvSpPr>
@@ -4347,7 +4599,7 @@
       </p:sp>
       <p:sp>
         <p:nvSpPr>
-          <p:cNvPr id="13" name="TextBox 12"/>
+          <p:cNvPr id="15" name="TextBox 14"/>
           <p:cNvSpPr txBox="1"/>
           <p:nvPr/>
         </p:nvSpPr>
@@ -4387,7 +4639,7 @@
       </p:sp>
       <p:sp>
         <p:nvSpPr>
-          <p:cNvPr id="14" name="TextBox 13"/>
+          <p:cNvPr id="16" name="TextBox 15"/>
           <p:cNvSpPr txBox="1"/>
           <p:nvPr/>
         </p:nvSpPr>
@@ -4420,14 +4672,14 @@
                 <a:latin typeface="PingFang SC"/>
                 <a:ea typeface="PingFang SC"/>
               </a:rPr>
-              <a:t>新闻与图片：中新网 · 2026年9月27日</a:t>
-            </a:r>
-          </a:p>
-        </p:txBody>
-      </p:sp>
-      <p:sp>
-        <p:nvSpPr>
-          <p:cNvPr id="15" name="TextBox 14"/>
+              <a:t>新闻与图片：杭州网 · 2026年9月27日</a:t>
+            </a:r>
+          </a:p>
+        </p:txBody>
+      </p:sp>
+      <p:sp>
+        <p:nvSpPr>
+          <p:cNvPr id="17" name="TextBox 16"/>
           <p:cNvSpPr txBox="1"/>
           <p:nvPr/>
         </p:nvSpPr>

</xml_diff>